<commit_message>
Decision model: marketing-channel example, sensitivity analysis (+/-10%), CSV export
Co-authored-by: arena-agent <297053741+arena-agent@users.noreply.github.com>
</commit_message>
<xml_diff>
--- a/docs/decision-model/decision-model.pptx
+++ b/docs/decision-model/decision-model.pptx
@@ -3216,6 +3216,14 @@
               <a:t>[المسؤوليات والمواعيد ومؤشرات النجاح]</a:t>
             </a:r>
           </a:p>
+          <a:p>
+            <a:pPr algn="r" rtl="1">
+              <a:defRPr sz="2000"/>
+            </a:pPr>
+            <a:r>
+              <a:t>التفاصيل الكاملة في implementation-guide.md</a:t>
+            </a:r>
+          </a:p>
         </p:txBody>
       </p:sp>
     </p:spTree>
@@ -3290,7 +3298,7 @@
               <a:defRPr sz="2000"/>
             </a:pPr>
             <a:r>
-              <a:t>[وصف مختصر للمشكلة]</a:t>
+              <a:t>الحاجة إلى قناة تسويق رقمي لإطلاق منتج جديد بميزانية محدودة وجمهور مستهدف واضح.</a:t>
             </a:r>
           </a:p>
         </p:txBody>
@@ -3367,7 +3375,15 @@
               <a:defRPr sz="2000"/>
             </a:pPr>
             <a:r>
-              <a:t>[ما الذي نريد حسمه؟ ومن صاحب القرار؟]</a:t>
+              <a:t>اختيار قناة التسويق الرقمي الأنسب لإطلاق المنتج.</a:t>
+            </a:r>
+          </a:p>
+          <a:p>
+            <a:pPr algn="r" rtl="1">
+              <a:defRPr sz="2000"/>
+            </a:pPr>
+            <a:r>
+              <a:t>صاحب القرار: [يُحدد لاحقًا]</a:t>
             </a:r>
           </a:p>
         </p:txBody>
@@ -3548,6 +3564,14 @@
               <a:t>• توجيهي: ماذا نفعل؟</a:t>
             </a:r>
           </a:p>
+          <a:p>
+            <a:pPr algn="r" rtl="1">
+              <a:defRPr sz="2000"/>
+            </a:pPr>
+            <a:r>
+              <a:t>• تقييم: مصفوفة قرار مرجحة، واختبار حساسية للأوزان (±10%)</a:t>
+            </a:r>
+          </a:p>
         </p:txBody>
       </p:sp>
     </p:spTree>
@@ -3622,7 +3646,23 @@
               <a:defRPr sz="2000"/>
             </a:pPr>
             <a:r>
-              <a:t>[أهم 3 إلى 5 نتائج]</a:t>
+              <a:t>• البديل الأعلى درجة: مدفوعة (7.85)</a:t>
+            </a:r>
+          </a:p>
+          <a:p>
+            <a:pPr algn="r" rtl="1">
+              <a:defRPr sz="2000"/>
+            </a:pPr>
+            <a:r>
+              <a:t>• الفارق عن البديل الثاني: 1.20 نقطة</a:t>
+            </a:r>
+          </a:p>
+          <a:p>
+            <a:pPr algn="r" rtl="1">
+              <a:defRPr sz="2000"/>
+            </a:pPr>
+            <a:r>
+              <a:t>• الفائز ثابت في 10 من 10 سيناريو حساسية</a:t>
             </a:r>
           </a:p>
         </p:txBody>
@@ -3699,7 +3739,7 @@
               <a:defRPr sz="2000"/>
             </a:pPr>
             <a:r>
-              <a:t>• البديل A</a:t>
+              <a:t>• مدفوعة</a:t>
             </a:r>
           </a:p>
           <a:p>
@@ -3707,7 +3747,7 @@
               <a:defRPr sz="2000"/>
             </a:pPr>
             <a:r>
-              <a:t>• البديل B</a:t>
+              <a:t>• محتوى</a:t>
             </a:r>
           </a:p>
           <a:p>
@@ -3715,7 +3755,7 @@
               <a:defRPr sz="2000"/>
             </a:pPr>
             <a:r>
-              <a:t>• البديل C</a:t>
+              <a:t>• مؤثرون</a:t>
             </a:r>
           </a:p>
         </p:txBody>
@@ -3775,8 +3815,8 @@
           <p:nvPr/>
         </p:nvGraphicFramePr>
         <p:xfrm>
-          <a:off x="640080" y="1645920"/>
-          <a:ext cx="10972800" cy="3291840"/>
+          <a:off x="640080" y="1463040"/>
+          <a:ext cx="10972800" cy="3520440"/>
         </p:xfrm>
         <a:graphic>
           <a:graphicData uri="http://schemas.openxmlformats.org/drawingml/2006/table">
@@ -3791,7 +3831,7 @@
                 <a:gridCol w="2194560"/>
                 <a:gridCol w="2194560"/>
               </a:tblGrid>
-              <a:tr h="548640">
+              <a:tr h="502920">
                 <a:tc>
                   <a:txBody>
                     <a:bodyPr/>
@@ -3831,7 +3871,7 @@
                         <a:defRPr sz="1800"/>
                       </a:pPr>
                       <a:r>
-                        <a:t>البديل A</a:t>
+                        <a:t>البديل مدفوعة</a:t>
                       </a:r>
                     </a:p>
                   </a:txBody>
@@ -3846,7 +3886,7 @@
                         <a:defRPr sz="1800"/>
                       </a:pPr>
                       <a:r>
-                        <a:t>البديل B</a:t>
+                        <a:t>البديل محتوى</a:t>
                       </a:r>
                     </a:p>
                   </a:txBody>
@@ -3861,14 +3901,14 @@
                         <a:defRPr sz="1800"/>
                       </a:pPr>
                       <a:r>
-                        <a:t>البديل C</a:t>
+                        <a:t>البديل مؤثرون</a:t>
                       </a:r>
                     </a:p>
                   </a:txBody>
                   <a:tcPr/>
                 </a:tc>
               </a:tr>
-              <a:tr h="548640">
+              <a:tr h="502920">
                 <a:tc>
                   <a:txBody>
                     <a:bodyPr/>
@@ -3879,160 +3919,6 @@
                       </a:pPr>
                       <a:r>
                         <a:t>التكلفة</a:t>
-                      </a:r>
-                    </a:p>
-                  </a:txBody>
-                  <a:tcPr/>
-                </a:tc>
-                <a:tc>
-                  <a:txBody>
-                    <a:bodyPr/>
-                    <a:lstStyle/>
-                    <a:p>
-                      <a:pPr algn="r" rtl="1">
-                        <a:defRPr sz="1800"/>
-                      </a:pPr>
-                      <a:r>
-                        <a:t>0.30</a:t>
-                      </a:r>
-                    </a:p>
-                  </a:txBody>
-                  <a:tcPr/>
-                </a:tc>
-                <a:tc>
-                  <a:txBody>
-                    <a:bodyPr/>
-                    <a:lstStyle/>
-                    <a:p>
-                      <a:pPr algn="r" rtl="1">
-                        <a:defRPr sz="1800"/>
-                      </a:pPr>
-                      <a:r>
-                        <a:t>8</a:t>
-                      </a:r>
-                    </a:p>
-                  </a:txBody>
-                  <a:tcPr/>
-                </a:tc>
-                <a:tc>
-                  <a:txBody>
-                    <a:bodyPr/>
-                    <a:lstStyle/>
-                    <a:p>
-                      <a:pPr algn="r" rtl="1">
-                        <a:defRPr sz="1800"/>
-                      </a:pPr>
-                      <a:r>
-                        <a:t>7</a:t>
-                      </a:r>
-                    </a:p>
-                  </a:txBody>
-                  <a:tcPr/>
-                </a:tc>
-                <a:tc>
-                  <a:txBody>
-                    <a:bodyPr/>
-                    <a:lstStyle/>
-                    <a:p>
-                      <a:pPr algn="r" rtl="1">
-                        <a:defRPr sz="1800"/>
-                      </a:pPr>
-                      <a:r>
-                        <a:t>9</a:t>
-                      </a:r>
-                    </a:p>
-                  </a:txBody>
-                  <a:tcPr/>
-                </a:tc>
-              </a:tr>
-              <a:tr h="548640">
-                <a:tc>
-                  <a:txBody>
-                    <a:bodyPr/>
-                    <a:lstStyle/>
-                    <a:p>
-                      <a:pPr algn="r" rtl="1">
-                        <a:defRPr sz="1800"/>
-                      </a:pPr>
-                      <a:r>
-                        <a:t>السرعة</a:t>
-                      </a:r>
-                    </a:p>
-                  </a:txBody>
-                  <a:tcPr/>
-                </a:tc>
-                <a:tc>
-                  <a:txBody>
-                    <a:bodyPr/>
-                    <a:lstStyle/>
-                    <a:p>
-                      <a:pPr algn="r" rtl="1">
-                        <a:defRPr sz="1800"/>
-                      </a:pPr>
-                      <a:r>
-                        <a:t>0.20</a:t>
-                      </a:r>
-                    </a:p>
-                  </a:txBody>
-                  <a:tcPr/>
-                </a:tc>
-                <a:tc>
-                  <a:txBody>
-                    <a:bodyPr/>
-                    <a:lstStyle/>
-                    <a:p>
-                      <a:pPr algn="r" rtl="1">
-                        <a:defRPr sz="1800"/>
-                      </a:pPr>
-                      <a:r>
-                        <a:t>7</a:t>
-                      </a:r>
-                    </a:p>
-                  </a:txBody>
-                  <a:tcPr/>
-                </a:tc>
-                <a:tc>
-                  <a:txBody>
-                    <a:bodyPr/>
-                    <a:lstStyle/>
-                    <a:p>
-                      <a:pPr algn="r" rtl="1">
-                        <a:defRPr sz="1800"/>
-                      </a:pPr>
-                      <a:r>
-                        <a:t>9</a:t>
-                      </a:r>
-                    </a:p>
-                  </a:txBody>
-                  <a:tcPr/>
-                </a:tc>
-                <a:tc>
-                  <a:txBody>
-                    <a:bodyPr/>
-                    <a:lstStyle/>
-                    <a:p>
-                      <a:pPr algn="r" rtl="1">
-                        <a:defRPr sz="1800"/>
-                      </a:pPr>
-                      <a:r>
-                        <a:t>6</a:t>
-                      </a:r>
-                    </a:p>
-                  </a:txBody>
-                  <a:tcPr/>
-                </a:tc>
-              </a:tr>
-              <a:tr h="548640">
-                <a:tc>
-                  <a:txBody>
-                    <a:bodyPr/>
-                    <a:lstStyle/>
-                    <a:p>
-                      <a:pPr algn="r" rtl="1">
-                        <a:defRPr sz="1800"/>
-                      </a:pPr>
-                      <a:r>
-                        <a:t>المخاطر</a:t>
                       </a:r>
                     </a:p>
                   </a:txBody>
@@ -4077,7 +3963,7 @@
                         <a:defRPr sz="1800"/>
                       </a:pPr>
                       <a:r>
-                        <a:t>8</a:t>
+                        <a:t>9</a:t>
                       </a:r>
                     </a:p>
                   </a:txBody>
@@ -4099,7 +3985,7 @@
                   <a:tcPr/>
                 </a:tc>
               </a:tr>
-              <a:tr h="548640">
+              <a:tr h="502920">
                 <a:tc>
                   <a:txBody>
                     <a:bodyPr/>
@@ -4109,7 +3995,7 @@
                         <a:defRPr sz="1800"/>
                       </a:pPr>
                       <a:r>
-                        <a:t>الأثر الاستراتيجي</a:t>
+                        <a:t>الوصول للجمهور المستهدف</a:t>
                       </a:r>
                     </a:p>
                   </a:txBody>
@@ -4124,7 +4010,7 @@
                         <a:defRPr sz="1800"/>
                       </a:pPr>
                       <a:r>
-                        <a:t>0.25</a:t>
+                        <a:t>0.30</a:t>
                       </a:r>
                     </a:p>
                   </a:txBody>
@@ -4154,7 +4040,7 @@
                         <a:defRPr sz="1800"/>
                       </a:pPr>
                       <a:r>
-                        <a:t>7</a:t>
+                        <a:t>6</a:t>
                       </a:r>
                     </a:p>
                   </a:txBody>
@@ -4176,7 +4062,238 @@
                   <a:tcPr/>
                 </a:tc>
               </a:tr>
-              <a:tr h="548640">
+              <a:tr h="502920">
+                <a:tc>
+                  <a:txBody>
+                    <a:bodyPr/>
+                    <a:lstStyle/>
+                    <a:p>
+                      <a:pPr algn="r" rtl="1">
+                        <a:defRPr sz="1800"/>
+                      </a:pPr>
+                      <a:r>
+                        <a:t>سرعة النتائج</a:t>
+                      </a:r>
+                    </a:p>
+                  </a:txBody>
+                  <a:tcPr/>
+                </a:tc>
+                <a:tc>
+                  <a:txBody>
+                    <a:bodyPr/>
+                    <a:lstStyle/>
+                    <a:p>
+                      <a:pPr algn="r" rtl="1">
+                        <a:defRPr sz="1800"/>
+                      </a:pPr>
+                      <a:r>
+                        <a:t>0.20</a:t>
+                      </a:r>
+                    </a:p>
+                  </a:txBody>
+                  <a:tcPr/>
+                </a:tc>
+                <a:tc>
+                  <a:txBody>
+                    <a:bodyPr/>
+                    <a:lstStyle/>
+                    <a:p>
+                      <a:pPr algn="r" rtl="1">
+                        <a:defRPr sz="1800"/>
+                      </a:pPr>
+                      <a:r>
+                        <a:t>9</a:t>
+                      </a:r>
+                    </a:p>
+                  </a:txBody>
+                  <a:tcPr/>
+                </a:tc>
+                <a:tc>
+                  <a:txBody>
+                    <a:bodyPr/>
+                    <a:lstStyle/>
+                    <a:p>
+                      <a:pPr algn="r" rtl="1">
+                        <a:defRPr sz="1800"/>
+                      </a:pPr>
+                      <a:r>
+                        <a:t>4</a:t>
+                      </a:r>
+                    </a:p>
+                  </a:txBody>
+                  <a:tcPr/>
+                </a:tc>
+                <a:tc>
+                  <a:txBody>
+                    <a:bodyPr/>
+                    <a:lstStyle/>
+                    <a:p>
+                      <a:pPr algn="r" rtl="1">
+                        <a:defRPr sz="1800"/>
+                      </a:pPr>
+                      <a:r>
+                        <a:t>7</a:t>
+                      </a:r>
+                    </a:p>
+                  </a:txBody>
+                  <a:tcPr/>
+                </a:tc>
+              </a:tr>
+              <a:tr h="502920">
+                <a:tc>
+                  <a:txBody>
+                    <a:bodyPr/>
+                    <a:lstStyle/>
+                    <a:p>
+                      <a:pPr algn="r" rtl="1">
+                        <a:defRPr sz="1800"/>
+                      </a:pPr>
+                      <a:r>
+                        <a:t>قابلية القياس</a:t>
+                      </a:r>
+                    </a:p>
+                  </a:txBody>
+                  <a:tcPr/>
+                </a:tc>
+                <a:tc>
+                  <a:txBody>
+                    <a:bodyPr/>
+                    <a:lstStyle/>
+                    <a:p>
+                      <a:pPr algn="r" rtl="1">
+                        <a:defRPr sz="1800"/>
+                      </a:pPr>
+                      <a:r>
+                        <a:t>0.15</a:t>
+                      </a:r>
+                    </a:p>
+                  </a:txBody>
+                  <a:tcPr/>
+                </a:tc>
+                <a:tc>
+                  <a:txBody>
+                    <a:bodyPr/>
+                    <a:lstStyle/>
+                    <a:p>
+                      <a:pPr algn="r" rtl="1">
+                        <a:defRPr sz="1800"/>
+                      </a:pPr>
+                      <a:r>
+                        <a:t>9</a:t>
+                      </a:r>
+                    </a:p>
+                  </a:txBody>
+                  <a:tcPr/>
+                </a:tc>
+                <a:tc>
+                  <a:txBody>
+                    <a:bodyPr/>
+                    <a:lstStyle/>
+                    <a:p>
+                      <a:pPr algn="r" rtl="1">
+                        <a:defRPr sz="1800"/>
+                      </a:pPr>
+                      <a:r>
+                        <a:t>6</a:t>
+                      </a:r>
+                    </a:p>
+                  </a:txBody>
+                  <a:tcPr/>
+                </a:tc>
+                <a:tc>
+                  <a:txBody>
+                    <a:bodyPr/>
+                    <a:lstStyle/>
+                    <a:p>
+                      <a:pPr algn="r" rtl="1">
+                        <a:defRPr sz="1800"/>
+                      </a:pPr>
+                      <a:r>
+                        <a:t>5</a:t>
+                      </a:r>
+                    </a:p>
+                  </a:txBody>
+                  <a:tcPr/>
+                </a:tc>
+              </a:tr>
+              <a:tr h="502920">
+                <a:tc>
+                  <a:txBody>
+                    <a:bodyPr/>
+                    <a:lstStyle/>
+                    <a:p>
+                      <a:pPr algn="r" rtl="1">
+                        <a:defRPr sz="1800"/>
+                      </a:pPr>
+                      <a:r>
+                        <a:t>الاستدامة</a:t>
+                      </a:r>
+                    </a:p>
+                  </a:txBody>
+                  <a:tcPr/>
+                </a:tc>
+                <a:tc>
+                  <a:txBody>
+                    <a:bodyPr/>
+                    <a:lstStyle/>
+                    <a:p>
+                      <a:pPr algn="r" rtl="1">
+                        <a:defRPr sz="1800"/>
+                      </a:pPr>
+                      <a:r>
+                        <a:t>0.10</a:t>
+                      </a:r>
+                    </a:p>
+                  </a:txBody>
+                  <a:tcPr/>
+                </a:tc>
+                <a:tc>
+                  <a:txBody>
+                    <a:bodyPr/>
+                    <a:lstStyle/>
+                    <a:p>
+                      <a:pPr algn="r" rtl="1">
+                        <a:defRPr sz="1800"/>
+                      </a:pPr>
+                      <a:r>
+                        <a:t>5</a:t>
+                      </a:r>
+                    </a:p>
+                  </a:txBody>
+                  <a:tcPr/>
+                </a:tc>
+                <a:tc>
+                  <a:txBody>
+                    <a:bodyPr/>
+                    <a:lstStyle/>
+                    <a:p>
+                      <a:pPr algn="r" rtl="1">
+                        <a:defRPr sz="1800"/>
+                      </a:pPr>
+                      <a:r>
+                        <a:t>9</a:t>
+                      </a:r>
+                    </a:p>
+                  </a:txBody>
+                  <a:tcPr/>
+                </a:tc>
+                <a:tc>
+                  <a:txBody>
+                    <a:bodyPr/>
+                    <a:lstStyle/>
+                    <a:p>
+                      <a:pPr algn="r" rtl="1">
+                        <a:defRPr sz="1800"/>
+                      </a:pPr>
+                      <a:r>
+                        <a:t>4</a:t>
+                      </a:r>
+                    </a:p>
+                  </a:txBody>
+                  <a:tcPr/>
+                </a:tc>
+              </a:tr>
+              <a:tr h="502920">
                 <a:tc>
                   <a:txBody>
                     <a:bodyPr/>
@@ -4213,7 +4330,7 @@
                         <a:defRPr sz="1800"/>
                       </a:pPr>
                       <a:r>
-                        <a:t>7.55</a:t>
+                        <a:t>7.85</a:t>
                       </a:r>
                     </a:p>
                   </a:txBody>
@@ -4228,7 +4345,7 @@
                         <a:defRPr sz="1800"/>
                       </a:pPr>
                       <a:r>
-                        <a:t>7.65</a:t>
+                        <a:t>6.65</a:t>
                       </a:r>
                     </a:p>
                   </a:txBody>
@@ -4243,7 +4360,7 @@
                         <a:defRPr sz="1800"/>
                       </a:pPr>
                       <a:r>
-                        <a:t>7.15</a:t>
+                        <a:t>6.20</a:t>
                       </a:r>
                     </a:p>
                   </a:txBody>
@@ -4326,7 +4443,7 @@
               <a:defRPr sz="2000"/>
             </a:pPr>
             <a:r>
-              <a:t>التوصية: البديل B (الدرجة 7.65)</a:t>
+              <a:t>التوصية: مدفوعة (الدرجة 7.85)</a:t>
             </a:r>
           </a:p>
           <a:p>
@@ -4334,7 +4451,7 @@
               <a:defRPr sz="2000"/>
             </a:pPr>
             <a:r>
-              <a:t>الترتيب: A = 7.55 (المركز 2)، B = 7.65 (المركز 1)، C = 7.15 (المركز 3)</a:t>
+              <a:t>الترتيب: مدفوعة = 7.85 (المركز 1)، محتوى = 6.65 (المركز 2)، مؤثرون = 6.20 (المركز 3)</a:t>
             </a:r>
           </a:p>
           <a:p>
@@ -4342,7 +4459,15 @@
               <a:defRPr sz="2000"/>
             </a:pPr>
             <a:r>
-              <a:t>[السبب ومخاطر القرار]</a:t>
+              <a:t>الفائز ثابت في 10 من 10 سيناريو حساسية (تغيير الأوزان ±10%)</a:t>
+            </a:r>
+          </a:p>
+          <a:p>
+            <a:pPr algn="r" rtl="1">
+              <a:defRPr sz="2000"/>
+            </a:pPr>
+            <a:r>
+              <a:t>[المخاطر وخطة التعامل معها]</a:t>
             </a:r>
           </a:p>
         </p:txBody>

</xml_diff>

<commit_message>
Decision model: one-way sweep with exact tipping points, cross-references, CSV 07-sweep
Co-authored-by: arena-agent <297053741+arena-agent@users.noreply.github.com>
</commit_message>
<xml_diff>
--- a/docs/decision-model/decision-model.pptx
+++ b/docs/decision-model/decision-model.pptx
@@ -3662,7 +3662,15 @@
               <a:defRPr sz="2000"/>
             </a:pPr>
             <a:r>
-              <a:t>• الفائز ثابت في 10 من 10 سيناريو حساسية</a:t>
+              <a:t>• الفائز ثابت في 10 من 10 سيناريو حساسية (±10%)</a:t>
+            </a:r>
+          </a:p>
+          <a:p>
+            <a:pPr algn="r" rtl="1">
+              <a:defRPr sz="2000"/>
+            </a:pPr>
+            <a:r>
+              <a:t>• أقرب نقطة انقلاب: الاستدامة عند الوزن 0.31 (الحالي 0.10) ويصبح الفائز محتوى</a:t>
             </a:r>
           </a:p>
         </p:txBody>
@@ -4467,6 +4475,14 @@
               <a:defRPr sz="2000"/>
             </a:pPr>
             <a:r>
+              <a:t>• أقرب نقطة انقلاب: الاستدامة عند الوزن 0.31 (الحالي 0.10) ويصبح الفائز محتوى</a:t>
+            </a:r>
+          </a:p>
+          <a:p>
+            <a:pPr algn="r" rtl="1">
+              <a:defRPr sz="2000"/>
+            </a:pPr>
+            <a:r>
               <a:t>[المخاطر وخطة التعامل معها]</a:t>
             </a:r>
           </a:p>

</xml_diff>

<commit_message>
Decision model: safety margin (exact, worst-case) and joint two-criteria tipping points
Co-authored-by: arena-agent <297053741+arena-agent@users.noreply.github.com>
</commit_message>
<xml_diff>
--- a/docs/decision-model/decision-model.pptx
+++ b/docs/decision-model/decision-model.pptx
@@ -3671,6 +3671,22 @@
             </a:pPr>
             <a:r>
               <a:t>• أقرب نقطة انقلاب: الاستدامة عند الوزن 0.31 (الحالي 0.10) ويصبح الفائز محتوى</a:t>
+            </a:r>
+          </a:p>
+          <a:p>
+            <a:pPr algn="r" rtl="1">
+              <a:defRPr sz="2000"/>
+            </a:pPr>
+            <a:r>
+              <a:t>• هامش الأمان: الفائز يصمد أمام تغيير نسبي ±34% في كل الأوزان معًا</a:t>
+            </a:r>
+          </a:p>
+          <a:p>
+            <a:pPr algn="r" rtl="1">
+              <a:defRPr sz="2000"/>
+            </a:pPr>
+            <a:r>
+              <a:t>• أسرع انقلاب مشترك: التكلفة + الاستدامة عند +0.084 لكل منهما (محتوى)</a:t>
             </a:r>
           </a:p>
         </p:txBody>
@@ -4483,6 +4499,14 @@
               <a:defRPr sz="2000"/>
             </a:pPr>
             <a:r>
+              <a:t>• هامش الأمان: الفائز يصمد أمام تغيير نسبي ±34% في كل الأوزان معًا</a:t>
+            </a:r>
+          </a:p>
+          <a:p>
+            <a:pPr algn="r" rtl="1">
+              <a:defRPr sz="2000"/>
+            </a:pPr>
+            <a:r>
               <a:t>[المخاطر وخطة التعامل معها]</a:t>
             </a:r>
           </a:p>

</xml_diff>

<commit_message>
Clarify safety-margin wording: per-weight relative change, any combination
Co-authored-by: arena-agent <297053741+arena-agent@users.noreply.github.com>
</commit_message>
<xml_diff>
--- a/docs/decision-model/decision-model.pptx
+++ b/docs/decision-model/decision-model.pptx
@@ -3678,7 +3678,7 @@
               <a:defRPr sz="2000"/>
             </a:pPr>
             <a:r>
-              <a:t>• هامش الأمان: الفائز يصمد أمام تغيير نسبي ±34% في كل الأوزان معًا</a:t>
+              <a:t>• هامش الأمان: الفائز يصمد أمام تغيير نسبي ±34% لكل وزن على حدة، في أي تركيبة</a:t>
             </a:r>
           </a:p>
           <a:p>
@@ -4499,7 +4499,7 @@
               <a:defRPr sz="2000"/>
             </a:pPr>
             <a:r>
-              <a:t>• هامش الأمان: الفائز يصمد أمام تغيير نسبي ±34% في كل الأوزان معًا</a:t>
+              <a:t>• هامش الأمان: الفائز يصمد أمام تغيير نسبي ±34% لكل وزن على حدة، في أي تركيبة</a:t>
             </a:r>
           </a:p>
           <a:p>

</xml_diff>